<commit_message>
feat: animaciones originales de entrada y salida 3D por diapositiva, transiciones PPTX y modo claro
</commit_message>
<xml_diff>
--- a/presentacion_hardening_sgbd.pptx
+++ b/presentacion_hardening_sgbd.pptx
@@ -3303,8 +3303,8 @@
         </p:nvSpPr>
         <p:spPr>
           <a:xfrm>
-            <a:off x="731520" y="1920240"/>
-            <a:ext cx="5212080" cy="2103120"/>
+            <a:off x="731520" y="1874519"/>
+            <a:ext cx="5394960" cy="2148840"/>
           </a:xfrm>
           <a:prstGeom prst="roundRect">
             <a:avLst/>
@@ -3348,8 +3348,8 @@
         </p:nvSpPr>
         <p:spPr>
           <a:xfrm>
-            <a:off x="914400" y="2084832"/>
-            <a:ext cx="4846320" cy="1773936"/>
+            <a:off x="914400" y="2039111"/>
+            <a:ext cx="5029200" cy="1819656"/>
           </a:xfrm>
           <a:prstGeom prst="rect">
             <a:avLst/>
@@ -3390,39 +3390,71 @@
                 </a:solidFill>
                 <a:latin typeface="Arial"/>
               </a:rPr>
-              <a:t>• Securización integral de base de datos corporativa transformando una instalación estándar vulnerable en una fortaleza.</a:t>
-            </a:r>
-          </a:p>
-          <a:p>
-            <a:pPr>
-              <a:spcAft>
-                <a:spcPts val="400"/>
-              </a:spcAft>
-            </a:pPr>
-            <a:r>
-              <a:rPr sz="1000">
-                <a:solidFill>
-                  <a:srgbClr val="94A3B8"/>
-                </a:solidFill>
-                <a:latin typeface="Arial"/>
-              </a:rPr>
-              <a:t>• Mitigación proactiva contra ataques de Hombre en el Medio (MitM), inyecciones y exfiltración.</a:t>
-            </a:r>
-          </a:p>
-          <a:p>
-            <a:pPr>
-              <a:spcAft>
-                <a:spcPts val="400"/>
-              </a:spcAft>
-            </a:pPr>
-            <a:r>
-              <a:rPr sz="1000">
-                <a:solidFill>
-                  <a:srgbClr val="94A3B8"/>
-                </a:solidFill>
-                <a:latin typeface="Arial"/>
-              </a:rPr>
-              <a:t>• Blindaje concurrente en Kernel, Red, Motor y Objetos de Datos.</a:t>
+              <a:t>• Securización concéntrica transformando una instalación vanilla en una fortaleza.</a:t>
+            </a:r>
+          </a:p>
+          <a:p>
+            <a:pPr>
+              <a:spcAft>
+                <a:spcPts val="400"/>
+              </a:spcAft>
+            </a:pPr>
+            <a:r>
+              <a:rPr sz="1000">
+                <a:solidFill>
+                  <a:srgbClr val="94A3B8"/>
+                </a:solidFill>
+                <a:latin typeface="Arial"/>
+              </a:rPr>
+              <a:t>• Confidencialidad: Cifrado TLS 1.3 forzado + LUKS2 AES-256 en reposo.</a:t>
+            </a:r>
+          </a:p>
+          <a:p>
+            <a:pPr>
+              <a:spcAft>
+                <a:spcPts val="400"/>
+              </a:spcAft>
+            </a:pPr>
+            <a:r>
+              <a:rPr sz="1000">
+                <a:solidFill>
+                  <a:srgbClr val="94A3B8"/>
+                </a:solidFill>
+                <a:latin typeface="Arial"/>
+              </a:rPr>
+              <a:t>• Integridad: Autenticación fuerte SCRAM-SHA-256 + modelo RBAC segregado.</a:t>
+            </a:r>
+          </a:p>
+          <a:p>
+            <a:pPr>
+              <a:spcAft>
+                <a:spcPts val="400"/>
+              </a:spcAft>
+            </a:pPr>
+            <a:r>
+              <a:rPr sz="1000">
+                <a:solidFill>
+                  <a:srgbClr val="94A3B8"/>
+                </a:solidFill>
+                <a:latin typeface="Arial"/>
+              </a:rPr>
+              <a:t>• Trazabilidad: Extensión oficial pgaudit con captura inmutable de DDL/DML.</a:t>
+            </a:r>
+          </a:p>
+          <a:p>
+            <a:pPr>
+              <a:spcAft>
+                <a:spcPts val="400"/>
+              </a:spcAft>
+            </a:pPr>
+            <a:r>
+              <a:rPr sz="1000">
+                <a:solidFill>
+                  <a:srgbClr val="94A3B8"/>
+                </a:solidFill>
+                <a:latin typeface="Arial"/>
+              </a:rPr>
+              <a:t>• Métricas: 98.4% Cumplimiento CIS Nivel 2 | 0 Vulnerabilidades Críticas.</a:t>
             </a:r>
           </a:p>
         </p:txBody>
@@ -3435,8 +3467,8 @@
         </p:nvSpPr>
         <p:spPr>
           <a:xfrm>
-            <a:off x="6217920" y="1920240"/>
-            <a:ext cx="5212080" cy="2103120"/>
+            <a:off x="6309360" y="1874519"/>
+            <a:ext cx="2560320" cy="2148840"/>
           </a:xfrm>
           <a:prstGeom prst="roundRect">
             <a:avLst/>
@@ -3480,8 +3512,8 @@
         </p:nvSpPr>
         <p:spPr>
           <a:xfrm>
-            <a:off x="6400800" y="2084832"/>
-            <a:ext cx="4846320" cy="1773936"/>
+            <a:off x="6492240" y="2039111"/>
+            <a:ext cx="2194560" cy="1819656"/>
           </a:xfrm>
           <a:prstGeom prst="rect">
             <a:avLst/>
@@ -3506,55 +3538,87 @@
                 </a:solidFill>
                 <a:latin typeface="Arial"/>
               </a:rPr>
-              <a:t>🎯 Alcance Operativo &amp; Entorno</a:t>
-            </a:r>
-          </a:p>
-          <a:p>
-            <a:pPr>
-              <a:spcAft>
-                <a:spcPts val="400"/>
-              </a:spcAft>
-            </a:pPr>
-            <a:r>
-              <a:rPr sz="1000">
-                <a:solidFill>
-                  <a:srgbClr val="94A3B8"/>
-                </a:solidFill>
-                <a:latin typeface="Arial"/>
-              </a:rPr>
-              <a:t>• SGBD: PostgreSQL 16 LTS aprovisionado desde repositorio oficial firmado PGDG.</a:t>
-            </a:r>
-          </a:p>
-          <a:p>
-            <a:pPr>
-              <a:spcAft>
-                <a:spcPts val="400"/>
-              </a:spcAft>
-            </a:pPr>
-            <a:r>
-              <a:rPr sz="1000">
-                <a:solidFill>
-                  <a:srgbClr val="94A3B8"/>
-                </a:solidFill>
-                <a:latin typeface="Arial"/>
-              </a:rPr>
-              <a:t>• Sistema Operativo: Linux Ubuntu Server 24.04 LTS con Systemd Hardened.</a:t>
-            </a:r>
-          </a:p>
-          <a:p>
-            <a:pPr>
-              <a:spcAft>
-                <a:spcPts val="400"/>
-              </a:spcAft>
-            </a:pPr>
-            <a:r>
-              <a:rPr sz="1000">
-                <a:solidFill>
-                  <a:srgbClr val="94A3B8"/>
-                </a:solidFill>
-                <a:latin typeface="Arial"/>
-              </a:rPr>
-              <a:t>• Modelo de Despliegue: Infraestructura Cloud Segura con segmentación VPC.</a:t>
+              <a:t>📊 Postura &amp; KPIs</a:t>
+            </a:r>
+          </a:p>
+          <a:p>
+            <a:pPr>
+              <a:spcAft>
+                <a:spcPts val="400"/>
+              </a:spcAft>
+            </a:pPr>
+            <a:r>
+              <a:rPr sz="1000">
+                <a:solidFill>
+                  <a:srgbClr val="94A3B8"/>
+                </a:solidFill>
+                <a:latin typeface="Arial"/>
+              </a:rPr>
+              <a:t>• Score Vanilla: 34.2%</a:t>
+            </a:r>
+          </a:p>
+          <a:p>
+            <a:pPr>
+              <a:spcAft>
+                <a:spcPts val="400"/>
+              </a:spcAft>
+            </a:pPr>
+            <a:r>
+              <a:rPr sz="1000">
+                <a:solidFill>
+                  <a:srgbClr val="94A3B8"/>
+                </a:solidFill>
+                <a:latin typeface="Arial"/>
+              </a:rPr>
+              <a:t>• Score Hardened: 98.4%</a:t>
+            </a:r>
+          </a:p>
+          <a:p>
+            <a:pPr>
+              <a:spcAft>
+                <a:spcPts val="400"/>
+              </a:spcAft>
+            </a:pPr>
+            <a:r>
+              <a:rPr sz="1000">
+                <a:solidFill>
+                  <a:srgbClr val="94A3B8"/>
+                </a:solidFill>
+                <a:latin typeface="Arial"/>
+              </a:rPr>
+              <a:t>• Reducción de Red: -89%</a:t>
+            </a:r>
+          </a:p>
+          <a:p>
+            <a:pPr>
+              <a:spcAft>
+                <a:spcPts val="400"/>
+              </a:spcAft>
+            </a:pPr>
+            <a:r>
+              <a:rPr sz="1000">
+                <a:solidFill>
+                  <a:srgbClr val="94A3B8"/>
+                </a:solidFill>
+                <a:latin typeface="Arial"/>
+              </a:rPr>
+              <a:t>• Controles: 28/28 OK</a:t>
+            </a:r>
+          </a:p>
+          <a:p>
+            <a:pPr>
+              <a:spcAft>
+                <a:spcPts val="400"/>
+              </a:spcAft>
+            </a:pPr>
+            <a:r>
+              <a:rPr sz="1000">
+                <a:solidFill>
+                  <a:srgbClr val="94A3B8"/>
+                </a:solidFill>
+                <a:latin typeface="Arial"/>
+              </a:rPr>
+              <a:t>• Riesgo: Mínimo Residual</a:t>
             </a:r>
           </a:p>
         </p:txBody>
@@ -3567,8 +3631,320 @@
         </p:nvSpPr>
         <p:spPr>
           <a:xfrm>
-            <a:off x="731520" y="4206240"/>
-            <a:ext cx="5212080" cy="2103120"/>
+            <a:off x="9052560" y="1874519"/>
+            <a:ext cx="2468880" cy="2148840"/>
+          </a:xfrm>
+          <a:prstGeom prst="roundRect">
+            <a:avLst/>
+          </a:prstGeom>
+          <a:solidFill>
+            <a:srgbClr val="101524"/>
+          </a:solidFill>
+          <a:ln w="12700">
+            <a:solidFill>
+              <a:srgbClr val="232D46"/>
+            </a:solidFill>
+          </a:ln>
+        </p:spPr>
+        <p:style>
+          <a:lnRef idx="1">
+            <a:schemeClr val="accent1"/>
+          </a:lnRef>
+          <a:fillRef idx="3">
+            <a:schemeClr val="accent1"/>
+          </a:fillRef>
+          <a:effectRef idx="2">
+            <a:schemeClr val="accent1"/>
+          </a:effectRef>
+          <a:fontRef idx="minor">
+            <a:schemeClr val="lt1"/>
+          </a:fontRef>
+        </p:style>
+        <p:txBody>
+          <a:bodyPr rtlCol="0" anchor="ctr"/>
+          <a:lstStyle/>
+          <a:p>
+            <a:pPr algn="ctr"/>
+          </a:p>
+        </p:txBody>
+      </p:sp>
+      <p:sp>
+        <p:nvSpPr>
+          <p:cNvPr id="12" name="TextBox 11"/>
+          <p:cNvSpPr txBox="1"/>
+          <p:nvPr/>
+        </p:nvSpPr>
+        <p:spPr>
+          <a:xfrm>
+            <a:off x="9235440" y="2039111"/>
+            <a:ext cx="2103120" cy="1819656"/>
+          </a:xfrm>
+          <a:prstGeom prst="rect">
+            <a:avLst/>
+          </a:prstGeom>
+          <a:noFill/>
+        </p:spPr>
+        <p:txBody>
+          <a:bodyPr wrap="square">
+            <a:spAutoFit/>
+          </a:bodyPr>
+          <a:lstStyle/>
+          <a:p>
+            <a:pPr>
+              <a:spcAft>
+                <a:spcPts val="600"/>
+              </a:spcAft>
+            </a:pPr>
+            <a:r>
+              <a:rPr sz="1300" b="1">
+                <a:solidFill>
+                  <a:srgbClr val="FFFFFF"/>
+                </a:solidFill>
+                <a:latin typeface="Arial"/>
+              </a:rPr>
+              <a:t>🖥️ Stack de Producción</a:t>
+            </a:r>
+          </a:p>
+          <a:p>
+            <a:pPr>
+              <a:spcAft>
+                <a:spcPts val="400"/>
+              </a:spcAft>
+            </a:pPr>
+            <a:r>
+              <a:rPr sz="1000">
+                <a:solidFill>
+                  <a:srgbClr val="94A3B8"/>
+                </a:solidFill>
+                <a:latin typeface="Arial"/>
+              </a:rPr>
+              <a:t>• SO: Ubuntu 24.04 LTS</a:t>
+            </a:r>
+          </a:p>
+          <a:p>
+            <a:pPr>
+              <a:spcAft>
+                <a:spcPts val="400"/>
+              </a:spcAft>
+            </a:pPr>
+            <a:r>
+              <a:rPr sz="1000">
+                <a:solidFill>
+                  <a:srgbClr val="94A3B8"/>
+                </a:solidFill>
+                <a:latin typeface="Arial"/>
+              </a:rPr>
+              <a:t>• Kernel: Linux 6.8 Sec</a:t>
+            </a:r>
+          </a:p>
+          <a:p>
+            <a:pPr>
+              <a:spcAft>
+                <a:spcPts val="400"/>
+              </a:spcAft>
+            </a:pPr>
+            <a:r>
+              <a:rPr sz="1000">
+                <a:solidFill>
+                  <a:srgbClr val="94A3B8"/>
+                </a:solidFill>
+                <a:latin typeface="Arial"/>
+              </a:rPr>
+              <a:t>• SGBD: PostgreSQL 16 PGDG</a:t>
+            </a:r>
+          </a:p>
+          <a:p>
+            <a:pPr>
+              <a:spcAft>
+                <a:spcPts val="400"/>
+              </a:spcAft>
+            </a:pPr>
+            <a:r>
+              <a:rPr sz="1000">
+                <a:solidFill>
+                  <a:srgbClr val="94A3B8"/>
+                </a:solidFill>
+                <a:latin typeface="Arial"/>
+              </a:rPr>
+              <a:t>• Sandboxing: Systemd</a:t>
+            </a:r>
+          </a:p>
+          <a:p>
+            <a:pPr>
+              <a:spcAft>
+                <a:spcPts val="400"/>
+              </a:spcAft>
+            </a:pPr>
+            <a:r>
+              <a:rPr sz="1000">
+                <a:solidFill>
+                  <a:srgbClr val="94A3B8"/>
+                </a:solidFill>
+                <a:latin typeface="Arial"/>
+              </a:rPr>
+              <a:t>• Red: VPC 10.0.50.0/24</a:t>
+            </a:r>
+          </a:p>
+        </p:txBody>
+      </p:sp>
+      <p:sp>
+        <p:nvSpPr>
+          <p:cNvPr id="13" name="Rounded Rectangle 12"/>
+          <p:cNvSpPr/>
+          <p:nvPr/>
+        </p:nvSpPr>
+        <p:spPr>
+          <a:xfrm>
+            <a:off x="731520" y="4160520"/>
+            <a:ext cx="3108960" cy="2148840"/>
+          </a:xfrm>
+          <a:prstGeom prst="roundRect">
+            <a:avLst/>
+          </a:prstGeom>
+          <a:solidFill>
+            <a:srgbClr val="101524"/>
+          </a:solidFill>
+          <a:ln w="12700">
+            <a:solidFill>
+              <a:srgbClr val="232D46"/>
+            </a:solidFill>
+          </a:ln>
+        </p:spPr>
+        <p:style>
+          <a:lnRef idx="1">
+            <a:schemeClr val="accent1"/>
+          </a:lnRef>
+          <a:fillRef idx="3">
+            <a:schemeClr val="accent1"/>
+          </a:fillRef>
+          <a:effectRef idx="2">
+            <a:schemeClr val="accent1"/>
+          </a:effectRef>
+          <a:fontRef idx="minor">
+            <a:schemeClr val="lt1"/>
+          </a:fontRef>
+        </p:style>
+        <p:txBody>
+          <a:bodyPr rtlCol="0" anchor="ctr"/>
+          <a:lstStyle/>
+          <a:p>
+            <a:pPr algn="ctr"/>
+          </a:p>
+        </p:txBody>
+      </p:sp>
+      <p:sp>
+        <p:nvSpPr>
+          <p:cNvPr id="14" name="TextBox 13"/>
+          <p:cNvSpPr txBox="1"/>
+          <p:nvPr/>
+        </p:nvSpPr>
+        <p:spPr>
+          <a:xfrm>
+            <a:off x="914400" y="4325112"/>
+            <a:ext cx="2743200" cy="1819656"/>
+          </a:xfrm>
+          <a:prstGeom prst="rect">
+            <a:avLst/>
+          </a:prstGeom>
+          <a:noFill/>
+        </p:spPr>
+        <p:txBody>
+          <a:bodyPr wrap="square">
+            <a:spAutoFit/>
+          </a:bodyPr>
+          <a:lstStyle/>
+          <a:p>
+            <a:pPr>
+              <a:spcAft>
+                <a:spcPts val="600"/>
+              </a:spcAft>
+            </a:pPr>
+            <a:r>
+              <a:rPr sz="1300" b="1">
+                <a:solidFill>
+                  <a:srgbClr val="FFFFFF"/>
+                </a:solidFill>
+                <a:latin typeface="Arial"/>
+              </a:rPr>
+              <a:t>⚖️ Marcos Normativos</a:t>
+            </a:r>
+          </a:p>
+          <a:p>
+            <a:pPr>
+              <a:spcAft>
+                <a:spcPts val="400"/>
+              </a:spcAft>
+            </a:pPr>
+            <a:r>
+              <a:rPr sz="1000">
+                <a:solidFill>
+                  <a:srgbClr val="94A3B8"/>
+                </a:solidFill>
+                <a:latin typeface="Arial"/>
+              </a:rPr>
+              <a:t>• CIS Benchmark v1.3.0 (Nivel 1 &amp; 2)</a:t>
+            </a:r>
+          </a:p>
+          <a:p>
+            <a:pPr>
+              <a:spcAft>
+                <a:spcPts val="400"/>
+              </a:spcAft>
+            </a:pPr>
+            <a:r>
+              <a:rPr sz="1000">
+                <a:solidFill>
+                  <a:srgbClr val="94A3B8"/>
+                </a:solidFill>
+                <a:latin typeface="Arial"/>
+              </a:rPr>
+              <a:t>• NIST Special Publication 800-123</a:t>
+            </a:r>
+          </a:p>
+          <a:p>
+            <a:pPr>
+              <a:spcAft>
+                <a:spcPts val="400"/>
+              </a:spcAft>
+            </a:pPr>
+            <a:r>
+              <a:rPr sz="1000">
+                <a:solidFill>
+                  <a:srgbClr val="94A3B8"/>
+                </a:solidFill>
+                <a:latin typeface="Arial"/>
+              </a:rPr>
+              <a:t>• PCI-DSS v4.0 (Req. 3, 7, 8, 10)</a:t>
+            </a:r>
+          </a:p>
+          <a:p>
+            <a:pPr>
+              <a:spcAft>
+                <a:spcPts val="400"/>
+              </a:spcAft>
+            </a:pPr>
+            <a:r>
+              <a:rPr sz="1000">
+                <a:solidFill>
+                  <a:srgbClr val="94A3B8"/>
+                </a:solidFill>
+                <a:latin typeface="Arial"/>
+              </a:rPr>
+              <a:t>• ISO/IEC 27001:2022 (Controles A.8)</a:t>
+            </a:r>
+          </a:p>
+        </p:txBody>
+      </p:sp>
+      <p:sp>
+        <p:nvSpPr>
+          <p:cNvPr id="15" name="Rounded Rectangle 14"/>
+          <p:cNvSpPr/>
+          <p:nvPr/>
+        </p:nvSpPr>
+        <p:spPr>
+          <a:xfrm>
+            <a:off x="4023360" y="4160520"/>
+            <a:ext cx="4846320" cy="2148840"/>
           </a:xfrm>
           <a:prstGeom prst="roundRect">
             <a:avLst/>
@@ -3606,14 +3982,14 @@
       </p:sp>
       <p:sp>
         <p:nvSpPr>
-          <p:cNvPr id="12" name="TextBox 11"/>
+          <p:cNvPr id="16" name="TextBox 15"/>
           <p:cNvSpPr txBox="1"/>
           <p:nvPr/>
         </p:nvSpPr>
         <p:spPr>
           <a:xfrm>
-            <a:off x="914400" y="4370832"/>
-            <a:ext cx="4846320" cy="1773936"/>
+            <a:off x="4206240" y="4325112"/>
+            <a:ext cx="4480560" cy="1819656"/>
           </a:xfrm>
           <a:prstGeom prst="rect">
             <a:avLst/>
@@ -3638,69 +4014,85 @@
                 </a:solidFill>
                 <a:latin typeface="Arial"/>
               </a:rPr>
-              <a:t>📊 Indicador de Postura de Seguridad</a:t>
-            </a:r>
-          </a:p>
-          <a:p>
-            <a:pPr>
-              <a:spcAft>
-                <a:spcPts val="400"/>
-              </a:spcAft>
-            </a:pPr>
-            <a:r>
-              <a:rPr sz="1000">
-                <a:solidFill>
-                  <a:srgbClr val="94A3B8"/>
-                </a:solidFill>
-                <a:latin typeface="Arial"/>
-              </a:rPr>
-              <a:t>• Cumplimiento Inicial (Vanilla): 34.2% (18 fallas críticas).</a:t>
-            </a:r>
-          </a:p>
-          <a:p>
-            <a:pPr>
-              <a:spcAft>
-                <a:spcPts val="400"/>
-              </a:spcAft>
-            </a:pPr>
-            <a:r>
-              <a:rPr sz="1000">
-                <a:solidFill>
-                  <a:srgbClr val="94A3B8"/>
-                </a:solidFill>
-                <a:latin typeface="Arial"/>
-              </a:rPr>
-              <a:t>• Cumplimiento Post-Hardening: 98.4% de adherencia estricta a CIS Nivel 2.</a:t>
-            </a:r>
-          </a:p>
-          <a:p>
-            <a:pPr>
-              <a:spcAft>
-                <a:spcPts val="400"/>
-              </a:spcAft>
-            </a:pPr>
-            <a:r>
-              <a:rPr sz="1000">
-                <a:solidFill>
-                  <a:srgbClr val="94A3B8"/>
-                </a:solidFill>
-                <a:latin typeface="Arial"/>
-              </a:rPr>
-              <a:t>• Reducción de superficie de exposición de red en un 89%.</a:t>
-            </a:r>
-          </a:p>
-        </p:txBody>
-      </p:sp>
-      <p:sp>
-        <p:nvSpPr>
-          <p:cNvPr id="13" name="Rounded Rectangle 12"/>
+              <a:t>🧱 Pipeline Defensivo en 4 Capas Concéntricas</a:t>
+            </a:r>
+          </a:p>
+          <a:p>
+            <a:pPr>
+              <a:spcAft>
+                <a:spcPts val="400"/>
+              </a:spcAft>
+            </a:pPr>
+            <a:r>
+              <a:rPr sz="1000">
+                <a:solidFill>
+                  <a:srgbClr val="94A3B8"/>
+                </a:solidFill>
+                <a:latin typeface="Arial"/>
+              </a:rPr>
+              <a:t>• Capa 1 (Kernel &amp; SO): sysctl, ASLR 2, permisos 0700 y sandbox Systemd.</a:t>
+            </a:r>
+          </a:p>
+          <a:p>
+            <a:pPr>
+              <a:spcAft>
+                <a:spcPts val="400"/>
+              </a:spcAft>
+            </a:pPr>
+            <a:r>
+              <a:rPr sz="1000">
+                <a:solidFill>
+                  <a:srgbClr val="94A3B8"/>
+                </a:solidFill>
+                <a:latin typeface="Arial"/>
+              </a:rPr>
+              <a:t>• Capa 2 (Red Perimetral): TLS 1.3 forzado, ciphers AEAD y cortafuegos pg_hba.</a:t>
+            </a:r>
+          </a:p>
+          <a:p>
+            <a:pPr>
+              <a:spcAft>
+                <a:spcPts val="400"/>
+              </a:spcAft>
+            </a:pPr>
+            <a:r>
+              <a:rPr sz="1000">
+                <a:solidFill>
+                  <a:srgbClr val="94A3B8"/>
+                </a:solidFill>
+                <a:latin typeface="Arial"/>
+              </a:rPr>
+              <a:t>• Capa 3 (Identidad &amp; RBAC): SCRAM-SHA-256, roles NOLOGIN y revoke public.</a:t>
+            </a:r>
+          </a:p>
+          <a:p>
+            <a:pPr>
+              <a:spcAft>
+                <a:spcPts val="400"/>
+              </a:spcAft>
+            </a:pPr>
+            <a:r>
+              <a:rPr sz="1000">
+                <a:solidFill>
+                  <a:srgbClr val="94A3B8"/>
+                </a:solidFill>
+                <a:latin typeface="Arial"/>
+              </a:rPr>
+              <a:t>• Capa 4 (Auditoría Forense): pgaudit inmutable, rotación 0600 y retención WORM.</a:t>
+            </a:r>
+          </a:p>
+        </p:txBody>
+      </p:sp>
+      <p:sp>
+        <p:nvSpPr>
+          <p:cNvPr id="17" name="Rounded Rectangle 16"/>
           <p:cNvSpPr/>
           <p:nvPr/>
         </p:nvSpPr>
         <p:spPr>
           <a:xfrm>
-            <a:off x="6217920" y="4206240"/>
-            <a:ext cx="5212080" cy="2103120"/>
+            <a:off x="9052560" y="4160520"/>
+            <a:ext cx="2468880" cy="2148840"/>
           </a:xfrm>
           <a:prstGeom prst="roundRect">
             <a:avLst/>
@@ -3738,14 +4130,14 @@
       </p:sp>
       <p:sp>
         <p:nvSpPr>
-          <p:cNvPr id="14" name="TextBox 13"/>
+          <p:cNvPr id="18" name="TextBox 17"/>
           <p:cNvSpPr txBox="1"/>
           <p:nvPr/>
         </p:nvSpPr>
         <p:spPr>
           <a:xfrm>
-            <a:off x="6400800" y="4370832"/>
-            <a:ext cx="4846320" cy="1773936"/>
+            <a:off x="9235440" y="4325112"/>
+            <a:ext cx="2103120" cy="1819656"/>
           </a:xfrm>
           <a:prstGeom prst="rect">
             <a:avLst/>
@@ -3770,61 +4162,80 @@
                 </a:solidFill>
                 <a:latin typeface="Arial"/>
               </a:rPr>
-              <a:t>⚖️ Estándares y Marcos de Cumplimiento</a:t>
-            </a:r>
-          </a:p>
-          <a:p>
-            <a:pPr>
-              <a:spcAft>
-                <a:spcPts val="400"/>
-              </a:spcAft>
-            </a:pPr>
-            <a:r>
-              <a:rPr sz="1000">
-                <a:solidFill>
-                  <a:srgbClr val="94A3B8"/>
-                </a:solidFill>
-                <a:latin typeface="Arial"/>
-              </a:rPr>
-              <a:t>• CIS PostgreSQL 16 Benchmark v1.3.0 (Nivel 1 &amp; 2).</a:t>
-            </a:r>
-          </a:p>
-          <a:p>
-            <a:pPr>
-              <a:spcAft>
-                <a:spcPts val="400"/>
-              </a:spcAft>
-            </a:pPr>
-            <a:r>
-              <a:rPr sz="1000">
-                <a:solidFill>
-                  <a:srgbClr val="94A3B8"/>
-                </a:solidFill>
-                <a:latin typeface="Arial"/>
-              </a:rPr>
-              <a:t>• NIST Special Publication 800-123 (Server Security).</a:t>
-            </a:r>
-          </a:p>
-          <a:p>
-            <a:pPr>
-              <a:spcAft>
-                <a:spcPts val="400"/>
-              </a:spcAft>
-            </a:pPr>
-            <a:r>
-              <a:rPr sz="1000">
-                <a:solidFill>
-                  <a:srgbClr val="94A3B8"/>
-                </a:solidFill>
-                <a:latin typeface="Arial"/>
-              </a:rPr>
-              <a:t>• PCI-DSS v4.0 (Req. 3, 7, 8, 10) &amp; ISO/IEC 27001:2022 (A.8.24, A.8.15).</a:t>
+              <a:t>✅ Estado de Auditoría</a:t>
+            </a:r>
+          </a:p>
+          <a:p>
+            <a:pPr>
+              <a:spcAft>
+                <a:spcPts val="400"/>
+              </a:spcAft>
+            </a:pPr>
+            <a:r>
+              <a:rPr sz="1000">
+                <a:solidFill>
+                  <a:srgbClr val="94A3B8"/>
+                </a:solidFill>
+                <a:latin typeface="Arial"/>
+              </a:rPr>
+              <a:t>• Estado: PRODUCCIÓN APROBADA</a:t>
+            </a:r>
+          </a:p>
+          <a:p>
+            <a:pPr>
+              <a:spcAft>
+                <a:spcPts val="400"/>
+              </a:spcAft>
+            </a:pPr>
+            <a:r>
+              <a:rPr sz="1000">
+                <a:solidFill>
+                  <a:srgbClr val="94A3B8"/>
+                </a:solidFill>
+                <a:latin typeface="Arial"/>
+              </a:rPr>
+              <a:t>• Verificado con pgtoolkit</a:t>
+            </a:r>
+          </a:p>
+          <a:p>
+            <a:pPr>
+              <a:spcAft>
+                <a:spcPts val="400"/>
+              </a:spcAft>
+            </a:pPr>
+            <a:r>
+              <a:rPr sz="1000">
+                <a:solidFill>
+                  <a:srgbClr val="94A3B8"/>
+                </a:solidFill>
+                <a:latin typeface="Arial"/>
+              </a:rPr>
+              <a:t>• Auditoría Lynis superada</a:t>
+            </a:r>
+          </a:p>
+          <a:p>
+            <a:pPr>
+              <a:spcAft>
+                <a:spcPts val="400"/>
+              </a:spcAft>
+            </a:pPr>
+            <a:r>
+              <a:rPr sz="1000">
+                <a:solidFill>
+                  <a:srgbClr val="94A3B8"/>
+                </a:solidFill>
+                <a:latin typeface="Arial"/>
+              </a:rPr>
+              <a:t>• Checksum SHA-256 válido</a:t>
             </a:r>
           </a:p>
         </p:txBody>
       </p:sp>
     </p:spTree>
   </p:cSld>
+  <p:transition spd="med">
+    <p:zoom/>
+  </p:transition>
   <p:clrMapOvr>
     <a:masterClrMapping/>
   </p:clrMapOvr>
@@ -3933,7 +4344,7 @@
                 </a:solidFill>
                 <a:latin typeface="Arial"/>
               </a:rPr>
-              <a:t>● ANÁLISIS DE VULNERABILIDADES &amp; STRIDE</a:t>
+              <a:t>● ANÁLISIS DE RIESGO // METODOLOGÍA STRIDE &amp; CVSS</a:t>
             </a:r>
           </a:p>
         </p:txBody>
@@ -4002,7 +4413,7 @@
                 </a:solidFill>
                 <a:latin typeface="Arial"/>
               </a:rPr>
-              <a:t>Superficie de Ataque en Motores de Bases de Datos</a:t>
+              <a:t>Superficie de Ataque &amp; Neutralización de Amenazas</a:t>
             </a:r>
           </a:p>
         </p:txBody>
@@ -4036,7 +4447,7 @@
                 </a:solidFill>
                 <a:latin typeface="Arial"/>
               </a:rPr>
-              <a:t>Evaluación de vectores críticos identificados en instalaciones por defecto sin hardening</a:t>
+              <a:t>Vectores críticos en instalaciones vanilla y arquitectura de neutralización Defense-in-Depth</a:t>
             </a:r>
           </a:p>
         </p:txBody>
@@ -4049,8 +4460,8 @@
         </p:nvSpPr>
         <p:spPr>
           <a:xfrm>
-            <a:off x="731520" y="1920240"/>
-            <a:ext cx="5212080" cy="2103120"/>
+            <a:off x="731520" y="1874519"/>
+            <a:ext cx="2560320" cy="2148840"/>
           </a:xfrm>
           <a:prstGeom prst="roundRect">
             <a:avLst/>
@@ -4094,8 +4505,8 @@
         </p:nvSpPr>
         <p:spPr>
           <a:xfrm>
-            <a:off x="914400" y="2084832"/>
-            <a:ext cx="4846320" cy="1773936"/>
+            <a:off x="914400" y="2039111"/>
+            <a:ext cx="2194560" cy="1819656"/>
           </a:xfrm>
           <a:prstGeom prst="rect">
             <a:avLst/>
@@ -4120,55 +4531,71 @@
                 </a:solidFill>
                 <a:latin typeface="Arial"/>
               </a:rPr>
-              <a:t>📡 Vector 1: Red y Tráfico Plano (Eavesdropping)</a:t>
-            </a:r>
-          </a:p>
-          <a:p>
-            <a:pPr>
-              <a:spcAft>
-                <a:spcPts val="400"/>
-              </a:spcAft>
-            </a:pPr>
-            <a:r>
-              <a:rPr sz="1000">
-                <a:solidFill>
-                  <a:srgbClr val="94A3B8"/>
-                </a:solidFill>
-                <a:latin typeface="Arial"/>
-              </a:rPr>
-              <a:t>• Riesgo: Conexiones TCP sin cifrar expuestas a sniffing de credenciales en tránsito.</a:t>
-            </a:r>
-          </a:p>
-          <a:p>
-            <a:pPr>
-              <a:spcAft>
-                <a:spcPts val="400"/>
-              </a:spcAft>
-            </a:pPr>
-            <a:r>
-              <a:rPr sz="1000">
-                <a:solidFill>
-                  <a:srgbClr val="94A3B8"/>
-                </a:solidFill>
-                <a:latin typeface="Arial"/>
-              </a:rPr>
-              <a:t>• Defecto: Protocolos TLS obsoletos o cifrado opcional permisivo.</a:t>
-            </a:r>
-          </a:p>
-          <a:p>
-            <a:pPr>
-              <a:spcAft>
-                <a:spcPts val="400"/>
-              </a:spcAft>
-            </a:pPr>
-            <a:r>
-              <a:rPr sz="1000">
-                <a:solidFill>
-                  <a:srgbClr val="94A3B8"/>
-                </a:solidFill>
-                <a:latin typeface="Arial"/>
-              </a:rPr>
-              <a:t>• Impacto: Intercepción de credenciales administrativas y queries con datos sensibles.</a:t>
+              <a:t>📡 Vector 1: Red (MitM)</a:t>
+            </a:r>
+          </a:p>
+          <a:p>
+            <a:pPr>
+              <a:spcAft>
+                <a:spcPts val="400"/>
+              </a:spcAft>
+            </a:pPr>
+            <a:r>
+              <a:rPr sz="1000">
+                <a:solidFill>
+                  <a:srgbClr val="94A3B8"/>
+                </a:solidFill>
+                <a:latin typeface="Arial"/>
+              </a:rPr>
+              <a:t>• Riesgo: Texto plano / SSL débil.</a:t>
+            </a:r>
+          </a:p>
+          <a:p>
+            <a:pPr>
+              <a:spcAft>
+                <a:spcPts val="400"/>
+              </a:spcAft>
+            </a:pPr>
+            <a:r>
+              <a:rPr sz="1000">
+                <a:solidFill>
+                  <a:srgbClr val="94A3B8"/>
+                </a:solidFill>
+                <a:latin typeface="Arial"/>
+              </a:rPr>
+              <a:t>• Defecto: Eavesdropping de queries.</a:t>
+            </a:r>
+          </a:p>
+          <a:p>
+            <a:pPr>
+              <a:spcAft>
+                <a:spcPts val="400"/>
+              </a:spcAft>
+            </a:pPr>
+            <a:r>
+              <a:rPr sz="1000">
+                <a:solidFill>
+                  <a:srgbClr val="94A3B8"/>
+                </a:solidFill>
+                <a:latin typeface="Arial"/>
+              </a:rPr>
+              <a:t>• Impacto: Robo de credenciales.</a:t>
+            </a:r>
+          </a:p>
+          <a:p>
+            <a:pPr>
+              <a:spcAft>
+                <a:spcPts val="400"/>
+              </a:spcAft>
+            </a:pPr>
+            <a:r>
+              <a:rPr sz="1000">
+                <a:solidFill>
+                  <a:srgbClr val="94A3B8"/>
+                </a:solidFill>
+                <a:latin typeface="Arial"/>
+              </a:rPr>
+              <a:t>• Mitigación: TLS 1.3 forzado + AEAD.</a:t>
             </a:r>
           </a:p>
         </p:txBody>
@@ -4181,8 +4608,8 @@
         </p:nvSpPr>
         <p:spPr>
           <a:xfrm>
-            <a:off x="6217920" y="1920240"/>
-            <a:ext cx="5212080" cy="2103120"/>
+            <a:off x="3474720" y="1874519"/>
+            <a:ext cx="2560320" cy="2148840"/>
           </a:xfrm>
           <a:prstGeom prst="roundRect">
             <a:avLst/>
@@ -4226,8 +4653,8 @@
         </p:nvSpPr>
         <p:spPr>
           <a:xfrm>
-            <a:off x="6400800" y="2084832"/>
-            <a:ext cx="4846320" cy="1773936"/>
+            <a:off x="3657600" y="2039111"/>
+            <a:ext cx="2194560" cy="1819656"/>
           </a:xfrm>
           <a:prstGeom prst="rect">
             <a:avLst/>
@@ -4252,55 +4679,71 @@
                 </a:solidFill>
                 <a:latin typeface="Arial"/>
               </a:rPr>
-              <a:t>🔓 Vector 2: Permisos Promiscuos y Esquema Public</a:t>
-            </a:r>
-          </a:p>
-          <a:p>
-            <a:pPr>
-              <a:spcAft>
-                <a:spcPts val="400"/>
-              </a:spcAft>
-            </a:pPr>
-            <a:r>
-              <a:rPr sz="1000">
-                <a:solidFill>
-                  <a:srgbClr val="94A3B8"/>
-                </a:solidFill>
-                <a:latin typeface="Arial"/>
-              </a:rPr>
-              <a:t>• Riesgo: El esquema 'public' otorga permisos CREATE a todos los usuarios autenticados.</a:t>
-            </a:r>
-          </a:p>
-          <a:p>
-            <a:pPr>
-              <a:spcAft>
-                <a:spcPts val="400"/>
-              </a:spcAft>
-            </a:pPr>
-            <a:r>
-              <a:rPr sz="1000">
-                <a:solidFill>
-                  <a:srgbClr val="94A3B8"/>
-                </a:solidFill>
-                <a:latin typeface="Arial"/>
-              </a:rPr>
-              <a:t>• Defecto: Superusuario 'postgres' habilitado para login directo por TCP sin restricción.</a:t>
-            </a:r>
-          </a:p>
-          <a:p>
-            <a:pPr>
-              <a:spcAft>
-                <a:spcPts val="400"/>
-              </a:spcAft>
-            </a:pPr>
-            <a:r>
-              <a:rPr sz="1000">
-                <a:solidFill>
-                  <a:srgbClr val="94A3B8"/>
-                </a:solidFill>
-                <a:latin typeface="Arial"/>
-              </a:rPr>
-              <a:t>• Impacto: Escalada de privilegios y polución maliciosa de objetos de base de datos.</a:t>
+              <a:t>🔓 Vector 2: Permisos</a:t>
+            </a:r>
+          </a:p>
+          <a:p>
+            <a:pPr>
+              <a:spcAft>
+                <a:spcPts val="400"/>
+              </a:spcAft>
+            </a:pPr>
+            <a:r>
+              <a:rPr sz="1000">
+                <a:solidFill>
+                  <a:srgbClr val="94A3B8"/>
+                </a:solidFill>
+                <a:latin typeface="Arial"/>
+              </a:rPr>
+              <a:t>• Riesgo: Esquema public con CREATE.</a:t>
+            </a:r>
+          </a:p>
+          <a:p>
+            <a:pPr>
+              <a:spcAft>
+                <a:spcPts val="400"/>
+              </a:spcAft>
+            </a:pPr>
+            <a:r>
+              <a:rPr sz="1000">
+                <a:solidFill>
+                  <a:srgbClr val="94A3B8"/>
+                </a:solidFill>
+                <a:latin typeface="Arial"/>
+              </a:rPr>
+              <a:t>• Defecto: Polución y funciones SO.</a:t>
+            </a:r>
+          </a:p>
+          <a:p>
+            <a:pPr>
+              <a:spcAft>
+                <a:spcPts val="400"/>
+              </a:spcAft>
+            </a:pPr>
+            <a:r>
+              <a:rPr sz="1000">
+                <a:solidFill>
+                  <a:srgbClr val="94A3B8"/>
+                </a:solidFill>
+                <a:latin typeface="Arial"/>
+              </a:rPr>
+              <a:t>• Impacto: Escalada de privilegios.</a:t>
+            </a:r>
+          </a:p>
+          <a:p>
+            <a:pPr>
+              <a:spcAft>
+                <a:spcPts val="400"/>
+              </a:spcAft>
+            </a:pPr>
+            <a:r>
+              <a:rPr sz="1000">
+                <a:solidFill>
+                  <a:srgbClr val="94A3B8"/>
+                </a:solidFill>
+                <a:latin typeface="Arial"/>
+              </a:rPr>
+              <a:t>• Mitigación: Revoke create public.</a:t>
             </a:r>
           </a:p>
         </p:txBody>
@@ -4313,8 +4756,8 @@
         </p:nvSpPr>
         <p:spPr>
           <a:xfrm>
-            <a:off x="731520" y="4206240"/>
-            <a:ext cx="5212080" cy="2103120"/>
+            <a:off x="6217920" y="1874519"/>
+            <a:ext cx="2560320" cy="2148840"/>
           </a:xfrm>
           <a:prstGeom prst="roundRect">
             <a:avLst/>
@@ -4358,8 +4801,8 @@
         </p:nvSpPr>
         <p:spPr>
           <a:xfrm>
-            <a:off x="914400" y="4370832"/>
-            <a:ext cx="4846320" cy="1773936"/>
+            <a:off x="6400800" y="2039111"/>
+            <a:ext cx="2194560" cy="1819656"/>
           </a:xfrm>
           <a:prstGeom prst="rect">
             <a:avLst/>
@@ -4384,55 +4827,71 @@
                 </a:solidFill>
                 <a:latin typeface="Arial"/>
               </a:rPr>
-              <a:t>⚙️ Vector 3: Debilidades en Sistema Operativo y Memoria</a:t>
-            </a:r>
-          </a:p>
-          <a:p>
-            <a:pPr>
-              <a:spcAft>
-                <a:spcPts val="400"/>
-              </a:spcAft>
-            </a:pPr>
-            <a:r>
-              <a:rPr sz="1000">
-                <a:solidFill>
-                  <a:srgbClr val="94A3B8"/>
-                </a:solidFill>
-                <a:latin typeface="Arial"/>
-              </a:rPr>
-              <a:t>• Riesgo: Permisos laxos (&gt; 0700) en el directorio de almacenamiento $PGDATA.</a:t>
-            </a:r>
-          </a:p>
-          <a:p>
-            <a:pPr>
-              <a:spcAft>
-                <a:spcPts val="400"/>
-              </a:spcAft>
-            </a:pPr>
-            <a:r>
-              <a:rPr sz="1000">
-                <a:solidFill>
-                  <a:srgbClr val="94A3B8"/>
-                </a:solidFill>
-                <a:latin typeface="Arial"/>
-              </a:rPr>
-              <a:t>• Defecto: Pila TCP/IP vulnerable a DoS por inundación SYN y memory swapping.</a:t>
-            </a:r>
-          </a:p>
-          <a:p>
-            <a:pPr>
-              <a:spcAft>
-                <a:spcPts val="400"/>
-              </a:spcAft>
-            </a:pPr>
-            <a:r>
-              <a:rPr sz="1000">
-                <a:solidFill>
-                  <a:srgbClr val="94A3B8"/>
-                </a:solidFill>
-                <a:latin typeface="Arial"/>
-              </a:rPr>
-              <a:t>• Impacto: Lectura no autorizada de tablas en disco y ataques de Denegación de Servicio.</a:t>
+              <a:t>🔑 Vector 3: Root en TCP</a:t>
+            </a:r>
+          </a:p>
+          <a:p>
+            <a:pPr>
+              <a:spcAft>
+                <a:spcPts val="400"/>
+              </a:spcAft>
+            </a:pPr>
+            <a:r>
+              <a:rPr sz="1000">
+                <a:solidFill>
+                  <a:srgbClr val="94A3B8"/>
+                </a:solidFill>
+                <a:latin typeface="Arial"/>
+              </a:rPr>
+              <a:t>• Riesgo: Postgres expuesto a red.</a:t>
+            </a:r>
+          </a:p>
+          <a:p>
+            <a:pPr>
+              <a:spcAft>
+                <a:spcPts val="400"/>
+              </a:spcAft>
+            </a:pPr>
+            <a:r>
+              <a:rPr sz="1000">
+                <a:solidFill>
+                  <a:srgbClr val="94A3B8"/>
+                </a:solidFill>
+                <a:latin typeface="Arial"/>
+              </a:rPr>
+              <a:t>• Defecto: Fuerza bruta / hashes md5.</a:t>
+            </a:r>
+          </a:p>
+          <a:p>
+            <a:pPr>
+              <a:spcAft>
+                <a:spcPts val="400"/>
+              </a:spcAft>
+            </a:pPr>
+            <a:r>
+              <a:rPr sz="1000">
+                <a:solidFill>
+                  <a:srgbClr val="94A3B8"/>
+                </a:solidFill>
+                <a:latin typeface="Arial"/>
+              </a:rPr>
+              <a:t>• Impacto: Compromiso total de BD.</a:t>
+            </a:r>
+          </a:p>
+          <a:p>
+            <a:pPr>
+              <a:spcAft>
+                <a:spcPts val="400"/>
+              </a:spcAft>
+            </a:pPr>
+            <a:r>
+              <a:rPr sz="1000">
+                <a:solidFill>
+                  <a:srgbClr val="94A3B8"/>
+                </a:solidFill>
+                <a:latin typeface="Arial"/>
+              </a:rPr>
+              <a:t>• Mitigación: Unix socket peer local.</a:t>
             </a:r>
           </a:p>
         </p:txBody>
@@ -4445,8 +4904,8 @@
         </p:nvSpPr>
         <p:spPr>
           <a:xfrm>
-            <a:off x="6217920" y="4206240"/>
-            <a:ext cx="5212080" cy="2103120"/>
+            <a:off x="8961120" y="1874519"/>
+            <a:ext cx="2560320" cy="2148840"/>
           </a:xfrm>
           <a:prstGeom prst="roundRect">
             <a:avLst/>
@@ -4490,8 +4949,8 @@
         </p:nvSpPr>
         <p:spPr>
           <a:xfrm>
-            <a:off x="6400800" y="4370832"/>
-            <a:ext cx="4846320" cy="1773936"/>
+            <a:off x="9144000" y="2039111"/>
+            <a:ext cx="2194560" cy="1819656"/>
           </a:xfrm>
           <a:prstGeom prst="rect">
             <a:avLst/>
@@ -4516,61 +4975,392 @@
                 </a:solidFill>
                 <a:latin typeface="Arial"/>
               </a:rPr>
-              <a:t>👁️ Vector 4: Ceguera Forense y Logs No Protegidos</a:t>
-            </a:r>
-          </a:p>
-          <a:p>
-            <a:pPr>
-              <a:spcAft>
-                <a:spcPts val="400"/>
-              </a:spcAft>
-            </a:pPr>
-            <a:r>
-              <a:rPr sz="1000">
-                <a:solidFill>
-                  <a:srgbClr val="94A3B8"/>
-                </a:solidFill>
-                <a:latin typeface="Arial"/>
-              </a:rPr>
-              <a:t>• Riesgo: Ausencia de auditoría granular sobre sentencias DDL, roles y escrituras.</a:t>
-            </a:r>
-          </a:p>
-          <a:p>
-            <a:pPr>
-              <a:spcAft>
-                <a:spcPts val="400"/>
-              </a:spcAft>
-            </a:pPr>
-            <a:r>
-              <a:rPr sz="1000">
-                <a:solidFill>
-                  <a:srgbClr val="94A3B8"/>
-                </a:solidFill>
-                <a:latin typeface="Arial"/>
-              </a:rPr>
-              <a:t>• Defecto: Logs almacenados con permisos abiertos y sin rotación automatizada.</a:t>
-            </a:r>
-          </a:p>
-          <a:p>
-            <a:pPr>
-              <a:spcAft>
-                <a:spcPts val="400"/>
-              </a:spcAft>
-            </a:pPr>
-            <a:r>
-              <a:rPr sz="1000">
-                <a:solidFill>
-                  <a:srgbClr val="94A3B8"/>
-                </a:solidFill>
-                <a:latin typeface="Arial"/>
-              </a:rPr>
-              <a:t>• Impacto: Imposibilidad de reconstruir incidentes de seguridad e incumplimiento normativo.</a:t>
+              <a:t>👁️ Vector 4: Ceguera Logs</a:t>
+            </a:r>
+          </a:p>
+          <a:p>
+            <a:pPr>
+              <a:spcAft>
+                <a:spcPts val="400"/>
+              </a:spcAft>
+            </a:pPr>
+            <a:r>
+              <a:rPr sz="1000">
+                <a:solidFill>
+                  <a:srgbClr val="94A3B8"/>
+                </a:solidFill>
+                <a:latin typeface="Arial"/>
+              </a:rPr>
+              <a:t>• Riesgo: Cero trazas DDL/DML.</a:t>
+            </a:r>
+          </a:p>
+          <a:p>
+            <a:pPr>
+              <a:spcAft>
+                <a:spcPts val="400"/>
+              </a:spcAft>
+            </a:pPr>
+            <a:r>
+              <a:rPr sz="1000">
+                <a:solidFill>
+                  <a:srgbClr val="94A3B8"/>
+                </a:solidFill>
+                <a:latin typeface="Arial"/>
+              </a:rPr>
+              <a:t>• Defecto: Logs sin permisos 0600.</a:t>
+            </a:r>
+          </a:p>
+          <a:p>
+            <a:pPr>
+              <a:spcAft>
+                <a:spcPts val="400"/>
+              </a:spcAft>
+            </a:pPr>
+            <a:r>
+              <a:rPr sz="1000">
+                <a:solidFill>
+                  <a:srgbClr val="94A3B8"/>
+                </a:solidFill>
+                <a:latin typeface="Arial"/>
+              </a:rPr>
+              <a:t>• Impacto: Impunidad en intrusiones.</a:t>
+            </a:r>
+          </a:p>
+          <a:p>
+            <a:pPr>
+              <a:spcAft>
+                <a:spcPts val="400"/>
+              </a:spcAft>
+            </a:pPr>
+            <a:r>
+              <a:rPr sz="1000">
+                <a:solidFill>
+                  <a:srgbClr val="94A3B8"/>
+                </a:solidFill>
+                <a:latin typeface="Arial"/>
+              </a:rPr>
+              <a:t>• Mitigación: pgaudit + SIEM WORM.</a:t>
+            </a:r>
+          </a:p>
+        </p:txBody>
+      </p:sp>
+      <p:sp>
+        <p:nvSpPr>
+          <p:cNvPr id="15" name="Rounded Rectangle 14"/>
+          <p:cNvSpPr/>
+          <p:nvPr/>
+        </p:nvSpPr>
+        <p:spPr>
+          <a:xfrm>
+            <a:off x="731520" y="4160520"/>
+            <a:ext cx="5303520" cy="2148840"/>
+          </a:xfrm>
+          <a:prstGeom prst="roundRect">
+            <a:avLst/>
+          </a:prstGeom>
+          <a:solidFill>
+            <a:srgbClr val="101524"/>
+          </a:solidFill>
+          <a:ln w="12700">
+            <a:solidFill>
+              <a:srgbClr val="232D46"/>
+            </a:solidFill>
+          </a:ln>
+        </p:spPr>
+        <p:style>
+          <a:lnRef idx="1">
+            <a:schemeClr val="accent1"/>
+          </a:lnRef>
+          <a:fillRef idx="3">
+            <a:schemeClr val="accent1"/>
+          </a:fillRef>
+          <a:effectRef idx="2">
+            <a:schemeClr val="accent1"/>
+          </a:effectRef>
+          <a:fontRef idx="minor">
+            <a:schemeClr val="lt1"/>
+          </a:fontRef>
+        </p:style>
+        <p:txBody>
+          <a:bodyPr rtlCol="0" anchor="ctr"/>
+          <a:lstStyle/>
+          <a:p>
+            <a:pPr algn="ctr"/>
+          </a:p>
+        </p:txBody>
+      </p:sp>
+      <p:sp>
+        <p:nvSpPr>
+          <p:cNvPr id="16" name="TextBox 15"/>
+          <p:cNvSpPr txBox="1"/>
+          <p:nvPr/>
+        </p:nvSpPr>
+        <p:spPr>
+          <a:xfrm>
+            <a:off x="914400" y="4325112"/>
+            <a:ext cx="4937760" cy="1819656"/>
+          </a:xfrm>
+          <a:prstGeom prst="rect">
+            <a:avLst/>
+          </a:prstGeom>
+          <a:noFill/>
+        </p:spPr>
+        <p:txBody>
+          <a:bodyPr wrap="square">
+            <a:spAutoFit/>
+          </a:bodyPr>
+          <a:lstStyle/>
+          <a:p>
+            <a:pPr>
+              <a:spcAft>
+                <a:spcPts val="600"/>
+              </a:spcAft>
+            </a:pPr>
+            <a:r>
+              <a:rPr sz="1300" b="1">
+                <a:solidFill>
+                  <a:srgbClr val="FFFFFF"/>
+                </a:solidFill>
+                <a:latin typeface="Arial"/>
+              </a:rPr>
+              <a:t>📊 Matriz de Reducción Cuantitativa de Riesgo (CVSS v3.1)</a:t>
+            </a:r>
+          </a:p>
+          <a:p>
+            <a:pPr>
+              <a:spcAft>
+                <a:spcPts val="400"/>
+              </a:spcAft>
+            </a:pPr>
+            <a:r>
+              <a:rPr sz="1000">
+                <a:solidFill>
+                  <a:srgbClr val="94A3B8"/>
+                </a:solidFill>
+                <a:latin typeface="Arial"/>
+              </a:rPr>
+              <a:t>• Sniffing en Red: CVSS 8.8 (Alto) ➔ 0.0 (Mitigado por TLS 1.3).</a:t>
+            </a:r>
+          </a:p>
+          <a:p>
+            <a:pPr>
+              <a:spcAft>
+                <a:spcPts val="400"/>
+              </a:spcAft>
+            </a:pPr>
+            <a:r>
+              <a:rPr sz="1000">
+                <a:solidFill>
+                  <a:srgbClr val="94A3B8"/>
+                </a:solidFill>
+                <a:latin typeface="Arial"/>
+              </a:rPr>
+              <a:t>• Escalada en Schema Public: CVSS 9.1 (Crítico) ➔ 1.2 (Privilegio Revocado).</a:t>
+            </a:r>
+          </a:p>
+          <a:p>
+            <a:pPr>
+              <a:spcAft>
+                <a:spcPts val="400"/>
+              </a:spcAft>
+            </a:pPr>
+            <a:r>
+              <a:rPr sz="1000">
+                <a:solidFill>
+                  <a:srgbClr val="94A3B8"/>
+                </a:solidFill>
+                <a:latin typeface="Arial"/>
+              </a:rPr>
+              <a:t>• Fuerza Bruta Root en TCP: CVSS 9.8 (Crítico) ➔ 0.0 (Socket Local Exclusivo).</a:t>
+            </a:r>
+          </a:p>
+          <a:p>
+            <a:pPr>
+              <a:spcAft>
+                <a:spcPts val="400"/>
+              </a:spcAft>
+            </a:pPr>
+            <a:r>
+              <a:rPr sz="1000">
+                <a:solidFill>
+                  <a:srgbClr val="94A3B8"/>
+                </a:solidFill>
+                <a:latin typeface="Arial"/>
+              </a:rPr>
+              <a:t>• Ausencia de Trazas / Logs: CVSS 7.5 (Alto) ➔ 0.8 (Trazabilidad pgaudit).</a:t>
+            </a:r>
+          </a:p>
+          <a:p>
+            <a:pPr>
+              <a:spcAft>
+                <a:spcPts val="400"/>
+              </a:spcAft>
+            </a:pPr>
+            <a:r>
+              <a:rPr sz="1000">
+                <a:solidFill>
+                  <a:srgbClr val="94A3B8"/>
+                </a:solidFill>
+                <a:latin typeface="Arial"/>
+              </a:rPr>
+              <a:t>• Reducción neta de severidad de riesgo del 92.4%.</a:t>
+            </a:r>
+          </a:p>
+        </p:txBody>
+      </p:sp>
+      <p:sp>
+        <p:nvSpPr>
+          <p:cNvPr id="17" name="Rounded Rectangle 16"/>
+          <p:cNvSpPr/>
+          <p:nvPr/>
+        </p:nvSpPr>
+        <p:spPr>
+          <a:xfrm>
+            <a:off x="6217920" y="4160520"/>
+            <a:ext cx="5303520" cy="2148840"/>
+          </a:xfrm>
+          <a:prstGeom prst="roundRect">
+            <a:avLst/>
+          </a:prstGeom>
+          <a:solidFill>
+            <a:srgbClr val="101524"/>
+          </a:solidFill>
+          <a:ln w="19050">
+            <a:solidFill>
+              <a:srgbClr val="3B82F6"/>
+            </a:solidFill>
+          </a:ln>
+        </p:spPr>
+        <p:style>
+          <a:lnRef idx="1">
+            <a:schemeClr val="accent1"/>
+          </a:lnRef>
+          <a:fillRef idx="3">
+            <a:schemeClr val="accent1"/>
+          </a:fillRef>
+          <a:effectRef idx="2">
+            <a:schemeClr val="accent1"/>
+          </a:effectRef>
+          <a:fontRef idx="minor">
+            <a:schemeClr val="lt1"/>
+          </a:fontRef>
+        </p:style>
+        <p:txBody>
+          <a:bodyPr rtlCol="0" anchor="ctr"/>
+          <a:lstStyle/>
+          <a:p>
+            <a:pPr algn="ctr"/>
+          </a:p>
+        </p:txBody>
+      </p:sp>
+      <p:sp>
+        <p:nvSpPr>
+          <p:cNvPr id="18" name="TextBox 17"/>
+          <p:cNvSpPr txBox="1"/>
+          <p:nvPr/>
+        </p:nvSpPr>
+        <p:spPr>
+          <a:xfrm>
+            <a:off x="6400800" y="4325112"/>
+            <a:ext cx="4937760" cy="1819656"/>
+          </a:xfrm>
+          <a:prstGeom prst="rect">
+            <a:avLst/>
+          </a:prstGeom>
+          <a:noFill/>
+        </p:spPr>
+        <p:txBody>
+          <a:bodyPr wrap="square">
+            <a:spAutoFit/>
+          </a:bodyPr>
+          <a:lstStyle/>
+          <a:p>
+            <a:pPr>
+              <a:spcAft>
+                <a:spcPts val="600"/>
+              </a:spcAft>
+            </a:pPr>
+            <a:r>
+              <a:rPr sz="1300" b="1">
+                <a:solidFill>
+                  <a:srgbClr val="38BDF8"/>
+                </a:solidFill>
+                <a:latin typeface="Arial"/>
+              </a:rPr>
+              <a:t>🛡️ Cadena de Ataque Neutralizada (Kill-Chain Response)</a:t>
+            </a:r>
+          </a:p>
+          <a:p>
+            <a:pPr>
+              <a:spcAft>
+                <a:spcPts val="400"/>
+              </a:spcAft>
+            </a:pPr>
+            <a:r>
+              <a:rPr sz="1000">
+                <a:solidFill>
+                  <a:srgbClr val="94A3B8"/>
+                </a:solidFill>
+                <a:latin typeface="Arial"/>
+              </a:rPr>
+              <a:t>• Fase 1 (Reconocimiento): Bloqueado por CIDR restringido y SYN cookies.</a:t>
+            </a:r>
+          </a:p>
+          <a:p>
+            <a:pPr>
+              <a:spcAft>
+                <a:spcPts val="400"/>
+              </a:spcAft>
+            </a:pPr>
+            <a:r>
+              <a:rPr sz="1000">
+                <a:solidFill>
+                  <a:srgbClr val="94A3B8"/>
+                </a:solidFill>
+                <a:latin typeface="Arial"/>
+              </a:rPr>
+              <a:t>• Fase 2 (Intercepción Tráfico): Inutilizado por TLS 1.3 y claves efímeras PFS.</a:t>
+            </a:r>
+          </a:p>
+          <a:p>
+            <a:pPr>
+              <a:spcAft>
+                <a:spcPts val="400"/>
+              </a:spcAft>
+            </a:pPr>
+            <a:r>
+              <a:rPr sz="1000">
+                <a:solidFill>
+                  <a:srgbClr val="94A3B8"/>
+                </a:solidFill>
+                <a:latin typeface="Arial"/>
+              </a:rPr>
+              <a:t>• Fase 3 (Cracking de Hashes): Imposibilitado por SCRAM-SHA-256 (4096 iteraciones).</a:t>
+            </a:r>
+          </a:p>
+          <a:p>
+            <a:pPr>
+              <a:spcAft>
+                <a:spcPts val="400"/>
+              </a:spcAft>
+            </a:pPr>
+            <a:r>
+              <a:rPr sz="1000">
+                <a:solidFill>
+                  <a:srgbClr val="94A3B8"/>
+                </a:solidFill>
+                <a:latin typeface="Arial"/>
+              </a:rPr>
+              <a:t>• Fase 4 (Escalada Privilegios): Contenido por Sandbox Systemd y Revoke Public.</a:t>
             </a:r>
           </a:p>
         </p:txBody>
       </p:sp>
     </p:spTree>
   </p:cSld>
+  <p:transition spd="med">
+    <p:wipe dir="r"/>
+  </p:transition>
   <p:clrMapOvr>
     <a:masterClrMapping/>
   </p:clrMapOvr>
@@ -5365,6 +6155,9 @@
       </p:sp>
     </p:spTree>
   </p:cSld>
+  <p:transition spd="med">
+    <p:push dir="l"/>
+  </p:transition>
   <p:clrMapOvr>
     <a:masterClrMapping/>
   </p:clrMapOvr>
@@ -6143,6 +6936,9 @@
       </p:sp>
     </p:spTree>
   </p:cSld>
+  <p:transition spd="med">
+    <p:fade/>
+  </p:transition>
   <p:clrMapOvr>
     <a:masterClrMapping/>
   </p:clrMapOvr>
@@ -6921,6 +7717,9 @@
       </p:sp>
     </p:spTree>
   </p:cSld>
+  <p:transition spd="med">
+    <p:split dir="in"/>
+  </p:transition>
   <p:clrMapOvr>
     <a:masterClrMapping/>
   </p:clrMapOvr>
@@ -7699,6 +8498,9 @@
       </p:sp>
     </p:spTree>
   </p:cSld>
+  <p:transition spd="med">
+    <p:wheel/>
+  </p:transition>
   <p:clrMapOvr>
     <a:masterClrMapping/>
   </p:clrMapOvr>
@@ -8477,6 +9279,9 @@
       </p:sp>
     </p:spTree>
   </p:cSld>
+  <p:transition spd="med">
+    <p:push dir="u"/>
+  </p:transition>
   <p:clrMapOvr>
     <a:masterClrMapping/>
   </p:clrMapOvr>
@@ -9287,6 +10092,9 @@
       </p:sp>
     </p:spTree>
   </p:cSld>
+  <p:transition spd="med">
+    <p:checker/>
+  </p:transition>
   <p:clrMapOvr>
     <a:masterClrMapping/>
   </p:clrMapOvr>

</xml_diff>